<commit_message>
ship: delete outdated visual audit diagrams, regenerate 18 high-res diagrams, and synchronize documentation
</commit_message>
<xml_diff>
--- a/docs/FinConsent-Client-Presentation.pptx
+++ b/docs/FinConsent-Client-Presentation.pptx
@@ -5660,7 +5660,7 @@
               </a:defRPr>
             </a:pPr>
             <a:r>
-              <a:t>Enterprise Statutory Trade Authorization &amp; Tax Infrastructure for Indian RIAs</a:t>
+              <a:t>Enterprise Advisory Proposal Consent &amp; Tax Infrastructure for Indian RIAs</a:t>
             </a:r>
           </a:p>
           <a:p>
@@ -11922,7 +11922,7 @@
               </a:defRPr>
             </a:pPr>
             <a:r>
-              <a:t>1. Informal WhatsApp &amp; Email Approvals (Regulatory Rejection)</a:t>
+              <a:t>1. Informal Communication &amp; Evidentiary Fragmentation</a:t>
             </a:r>
           </a:p>
           <a:p>
@@ -11934,7 +11934,7 @@
               </a:defRPr>
             </a:pPr>
             <a:r>
-              <a:t>Advisers routinely gather approvals over text messages or calls. SEBI inspection teams reject informal communications under Regulation 19 record-keeping rules, leaving RIAs vulnerable to claims of unauthorized trading. Such communications fail Section 63 BSA electronic admissibility standards.</a:t>
+              <a:t>Advisers frequently communicate rebalancing proposals over chat or email. While discoverable, these unstructured records fragment rationale and create administrative collation overhead during SEBI Regulation 19 audits, failing Section 63 BSA electronic admissibility standards.</a:t>
             </a:r>
           </a:p>
         </p:txBody>

</xml_diff>